<commit_message>
refactor: streamline Slide 10 to strictly feature the 3 applied Column 2 references
</commit_message>
<xml_diff>
--- a/Varsity_RecSys_Presentation.pptx
+++ b/Varsity_RecSys_Presentation.pptx
@@ -3753,7 +3753,7 @@
               </a:defRPr>
             </a:pPr>
             <a:r>
-              <a:t>INDUSTRY DESIGN BLUEPRINTS &amp; APPLIED RESEARCH</a:t>
+              <a:t>SYSTEM ARCHITECTURE, COLLABORATIVE FILTERING &amp; BOTNET DEFENSE</a:t>
             </a:r>
           </a:p>
           <a:p>
@@ -3766,7 +3766,7 @@
               </a:defRPr>
             </a:pPr>
             <a:r>
-              <a:t>Project References &amp; Architecture Foundations</a:t>
+              <a:t>Project References &amp; Applied Foundations</a:t>
             </a:r>
           </a:p>
         </p:txBody>
@@ -3780,7 +3780,7 @@
         <p:spPr>
           <a:xfrm>
             <a:off x="731520" y="1600200"/>
-            <a:ext cx="5120640" cy="2240280"/>
+            <a:ext cx="10728655" cy="1417320"/>
           </a:xfrm>
           <a:prstGeom prst="roundRect">
             <a:avLst/>
@@ -3825,7 +3825,7 @@
         <p:spPr>
           <a:xfrm>
             <a:off x="969264" y="1783080"/>
-            <a:ext cx="4645152" cy="1874520"/>
+            <a:ext cx="10253167" cy="1051560"/>
           </a:xfrm>
           <a:prstGeom prst="rect">
             <a:avLst/>
@@ -3850,7 +3850,7 @@
               </a:defRPr>
             </a:pPr>
             <a:r>
-              <a:t>X Corp. / Twitter Open Source (2023)</a:t>
+              <a:t>1. X Corp. / Twitter Open Source (2023)</a:t>
             </a:r>
           </a:p>
           <a:p>
@@ -3882,7 +3882,7 @@
               </a:defRPr>
             </a:pPr>
             <a:r>
-              <a:t>• Architectural Blueprint for Varsity's Multi-Stage Lifecycle:</a:t>
+              <a:t>• Architectural Blueprint for Varsity's 4-Stage Feed Pipeline:</a:t>
             </a:r>
           </a:p>
           <a:p>
@@ -3898,7 +3898,7 @@
               </a:defRPr>
             </a:pPr>
             <a:r>
-              <a:t>   - Sub-5ms Candidate Sourcing (In-Network + Out-Network) →</a:t>
+              <a:t>   - Sourcing: Sub-5ms parallel retrieval across graph walks, iALS, and neural candidates.</a:t>
             </a:r>
           </a:p>
           <a:p>
@@ -3914,23 +3914,7 @@
               </a:defRPr>
             </a:pPr>
             <a:r>
-              <a:t>   - 12-Dimensional Feature Hydration → Calibrated Heavy Ranking →</a:t>
-            </a:r>
-          </a:p>
-          <a:p>
-            <a:pPr>
-              <a:spcAft>
-                <a:spcPts val="350"/>
-              </a:spcAft>
-              <a:defRPr sz="1300">
-                <a:solidFill>
-                  <a:srgbClr val="3F3F46"/>
-                </a:solidFill>
-                <a:latin typeface="Calibri"/>
-              </a:defRPr>
-            </a:pPr>
-            <a:r>
-              <a:t>   - Diversity Mixing &amp; Social Network graph traversal.</a:t>
+              <a:t>   - Ranking &amp; Delivery: 12-dimensional feature hydration, multi-action scoring, and MMR diversity mixing.</a:t>
             </a:r>
           </a:p>
         </p:txBody>
@@ -3943,8 +3927,8 @@
         </p:nvSpPr>
         <p:spPr>
           <a:xfrm>
-            <a:off x="6309360" y="1600200"/>
-            <a:ext cx="5120640" cy="2240280"/>
+            <a:off x="731520" y="3200400"/>
+            <a:ext cx="10728655" cy="1417320"/>
           </a:xfrm>
           <a:prstGeom prst="roundRect">
             <a:avLst/>
@@ -3988,8 +3972,8 @@
         </p:nvSpPr>
         <p:spPr>
           <a:xfrm>
-            <a:off x="6547104" y="1783080"/>
-            <a:ext cx="4645152" cy="1874520"/>
+            <a:off x="969264" y="3383280"/>
+            <a:ext cx="10253167" cy="1051560"/>
           </a:xfrm>
           <a:prstGeom prst="rect">
             <a:avLst/>
@@ -4014,7 +3998,7 @@
               </a:defRPr>
             </a:pPr>
             <a:r>
-              <a:t>Yifan Hu, Yehuda Koren, Chris Volinsky (2008)</a:t>
+              <a:t>2. Sarwar, Karypis, Konstan, Riedl (2001)</a:t>
             </a:r>
           </a:p>
           <a:p>
@@ -4030,7 +4014,7 @@
               </a:defRPr>
             </a:pPr>
             <a:r>
-              <a:t>'Collaborative Filtering for Implicit Feedback Datasets', IEEE ICDM</a:t>
+              <a:t>'Item-Based Collaborative Filtering Recommendation Algorithms', ACM WWW</a:t>
             </a:r>
           </a:p>
           <a:p>
@@ -4046,7 +4030,7 @@
               </a:defRPr>
             </a:pPr>
             <a:r>
-              <a:t>• Mathematical Foundation for Implicit RecSys:</a:t>
+              <a:t>• Foundations for Post-to-Post Similarity &amp; De-Biasing:</a:t>
             </a:r>
           </a:p>
           <a:p>
@@ -4062,7 +4046,7 @@
               </a:defRPr>
             </a:pPr>
             <a:r>
-              <a:t>   - Confidence matrix formulation: C_ui = 1 + α · r_ui</a:t>
+              <a:t>   - Item-kNN co-occurrence scoring and cosine similarity across interaction vectors.</a:t>
             </a:r>
           </a:p>
           <a:p>
@@ -4078,23 +4062,7 @@
               </a:defRPr>
             </a:pPr>
             <a:r>
-              <a:t>   - Alternating Least Squares (iALS) closed-form linear updates.</a:t>
-            </a:r>
-          </a:p>
-          <a:p>
-            <a:pPr>
-              <a:spcAft>
-                <a:spcPts val="350"/>
-              </a:spcAft>
-              <a:defRPr sz="1300">
-                <a:solidFill>
-                  <a:srgbClr val="3F3F46"/>
-                </a:solidFill>
-                <a:latin typeface="Calibri"/>
-              </a:defRPr>
-            </a:pPr>
-            <a:r>
-              <a:t>   - Core engine behind Varsity's 32-dim latent factor model.</a:t>
+              <a:t>   - Pearson correlation mean-centering to eliminate individual student rating bias.</a:t>
             </a:r>
           </a:p>
         </p:txBody>
@@ -4107,8 +4075,8 @@
         </p:nvSpPr>
         <p:spPr>
           <a:xfrm>
-            <a:off x="731520" y="4069080"/>
-            <a:ext cx="5120640" cy="2240280"/>
+            <a:off x="731520" y="4800600"/>
+            <a:ext cx="10728655" cy="1417320"/>
           </a:xfrm>
           <a:prstGeom prst="roundRect">
             <a:avLst/>
@@ -4152,8 +4120,8 @@
         </p:nvSpPr>
         <p:spPr>
           <a:xfrm>
-            <a:off x="969264" y="4251960"/>
-            <a:ext cx="4645152" cy="1874520"/>
+            <a:off x="969264" y="4983480"/>
+            <a:ext cx="10253167" cy="1051560"/>
           </a:xfrm>
           <a:prstGeom prst="rect">
             <a:avLst/>
@@ -4178,7 +4146,7 @@
               </a:defRPr>
             </a:pPr>
             <a:r>
-              <a:t>Robin Burke (2002)</a:t>
+              <a:t>3. Mobasher, Burke, Bhaumik, Williams (2007)</a:t>
             </a:r>
           </a:p>
           <a:p>
@@ -4194,7 +4162,7 @@
               </a:defRPr>
             </a:pPr>
             <a:r>
-              <a:t>'Hybrid Recommender Systems: Survey and Experiments', UMUAI</a:t>
+              <a:t>'Toward Trustworthy Recommender Systems: Analysis of Shilling Attacks', ACM TIST</a:t>
             </a:r>
           </a:p>
           <a:p>
@@ -4210,7 +4178,7 @@
               </a:defRPr>
             </a:pPr>
             <a:r>
-              <a:t>• Theoretical Taxonomy for Hybrid Systems:</a:t>
+              <a:t>• Security Blueprint for Varsity's Botnet Attack Sandbox &amp; Anomaly Detection:</a:t>
             </a:r>
           </a:p>
           <a:p>
@@ -4226,7 +4194,7 @@
               </a:defRPr>
             </a:pPr>
             <a:r>
-              <a:t>   - Switching Hybrid: Fallback from collaborative filtering to TF-IDF centroid matching when user interactions &lt; 3.</a:t>
+              <a:t>   - Models realistic attack profiles: Random noise injection and Bandwagon target promotion.</a:t>
             </a:r>
           </a:p>
           <a:p>
@@ -4242,155 +4210,7 @@
               </a:defRPr>
             </a:pPr>
             <a:r>
-              <a:t>   - Cascaded Ranking: Sourcing coarse candidates before fine-grained scoring.</a:t>
-            </a:r>
-          </a:p>
-        </p:txBody>
-      </p:sp>
-      <p:sp>
-        <p:nvSpPr>
-          <p:cNvPr id="10" name="Rounded Rectangle 9"/>
-          <p:cNvSpPr/>
-          <p:nvPr/>
-        </p:nvSpPr>
-        <p:spPr>
-          <a:xfrm>
-            <a:off x="6309360" y="4069080"/>
-            <a:ext cx="5120640" cy="2240280"/>
-          </a:xfrm>
-          <a:prstGeom prst="roundRect">
-            <a:avLst/>
-          </a:prstGeom>
-          <a:solidFill>
-            <a:srgbClr val="FFFFFF"/>
-          </a:solidFill>
-          <a:ln w="12700">
-            <a:solidFill>
-              <a:srgbClr val="E4E4E7"/>
-            </a:solidFill>
-          </a:ln>
-        </p:spPr>
-        <p:style>
-          <a:lnRef idx="1">
-            <a:schemeClr val="accent1"/>
-          </a:lnRef>
-          <a:fillRef idx="3">
-            <a:schemeClr val="accent1"/>
-          </a:fillRef>
-          <a:effectRef idx="2">
-            <a:schemeClr val="accent1"/>
-          </a:effectRef>
-          <a:fontRef idx="minor">
-            <a:schemeClr val="lt1"/>
-          </a:fontRef>
-        </p:style>
-        <p:txBody>
-          <a:bodyPr rtlCol="0" anchor="ctr"/>
-          <a:lstStyle/>
-          <a:p>
-            <a:pPr algn="ctr"/>
-          </a:p>
-        </p:txBody>
-      </p:sp>
-      <p:sp>
-        <p:nvSpPr>
-          <p:cNvPr id="11" name="TextBox 10"/>
-          <p:cNvSpPr txBox="1"/>
-          <p:nvPr/>
-        </p:nvSpPr>
-        <p:spPr>
-          <a:xfrm>
-            <a:off x="6547104" y="4251960"/>
-            <a:ext cx="4645152" cy="1874520"/>
-          </a:xfrm>
-          <a:prstGeom prst="rect">
-            <a:avLst/>
-          </a:prstGeom>
-          <a:noFill/>
-        </p:spPr>
-        <p:txBody>
-          <a:bodyPr wrap="square" lIns="0" tIns="0" rIns="0" bIns="0">
-            <a:spAutoFit/>
-          </a:bodyPr>
-          <a:lstStyle/>
-          <a:p>
-            <a:pPr>
-              <a:spcAft>
-                <a:spcPts val="200"/>
-              </a:spcAft>
-              <a:defRPr sz="1650" b="1">
-                <a:solidFill>
-                  <a:srgbClr val="C2410C"/>
-                </a:solidFill>
-                <a:latin typeface="Calibri"/>
-              </a:defRPr>
-            </a:pPr>
-            <a:r>
-              <a:t>Sarwar et al. (2001) &amp; Carbonell et al. (1998)</a:t>
-            </a:r>
-          </a:p>
-          <a:p>
-            <a:pPr>
-              <a:spcAft>
-                <a:spcPts val="400"/>
-              </a:spcAft>
-              <a:defRPr sz="1150" b="1">
-                <a:solidFill>
-                  <a:srgbClr val="0D9488"/>
-                </a:solidFill>
-                <a:latin typeface="Calibri"/>
-              </a:defRPr>
-            </a:pPr>
-            <a:r>
-              <a:t>'Item-Based Collaborative Filtering' (WWW) &amp; 'MMR Diversity' (SIGIR)</a:t>
-            </a:r>
-          </a:p>
-          <a:p>
-            <a:pPr>
-              <a:spcAft>
-                <a:spcPts val="350"/>
-              </a:spcAft>
-              <a:defRPr sz="1300">
-                <a:solidFill>
-                  <a:srgbClr val="3F3F46"/>
-                </a:solidFill>
-                <a:latin typeface="Calibri"/>
-              </a:defRPr>
-            </a:pPr>
-            <a:r>
-              <a:t>• Similarity De-biasing &amp; Diversity Re-Ranking:</a:t>
-            </a:r>
-          </a:p>
-          <a:p>
-            <a:pPr>
-              <a:spcAft>
-                <a:spcPts val="350"/>
-              </a:spcAft>
-              <a:defRPr sz="1300">
-                <a:solidFill>
-                  <a:srgbClr val="3F3F46"/>
-                </a:solidFill>
-                <a:latin typeface="Calibri"/>
-              </a:defRPr>
-            </a:pPr>
-            <a:r>
-              <a:t>   - Item-kNN co-occurrence, Pearson mean-centering &amp; significance weighting.</a:t>
-            </a:r>
-          </a:p>
-          <a:p>
-            <a:pPr>
-              <a:spcAft>
-                <a:spcPts val="350"/>
-              </a:spcAft>
-              <a:defRPr sz="1300">
-                <a:solidFill>
-                  <a:srgbClr val="3F3F46"/>
-                </a:solidFill>
-                <a:latin typeface="Calibri"/>
-              </a:defRPr>
-            </a:pPr>
-            <a:r>
-              <a:t>   - Maximal Marginal Relevance (MMR) trade-off between relevance and topic spread.</a:t>
+              <a:t>   - Unsupervised Jaccard graph overlap filter to flag and isolate coordinated sybil clusters.</a:t>
             </a:r>
           </a:p>
         </p:txBody>

</xml_diff>